<commit_message>
feat(frontend): give Seoul and Pohang the same river-band stage replay as Andong
사용자가 의성(안동) 사례의 재생 시각화를 기준으로 다른 사례도 같게 해 달라고 해서, 포항과 서울의 단계별 지도를 하천 양안 띠 규칙으로 통일했습니다.

- `create_case_hand_reconstruction.py`: 세 사례 공통으로 하천 선 양안 HAND 0.25 m 이하 셀을 비율²×2 km까지 넓힘. 포항 냉천 띠 0·0·236·370·403·415셀, 서울 stream 선 띠 405·1,031·1,216·1,218셀(신림P 60분 강우 비율)
- 서울 `hand_reconstruction`·`terrain` 레이어와 `UrbanConsole` 띠 레이어·토글·범례를 추가하고, 띠가 공식 흔적 대조에서 14~16%라 근거가 아니라 도식이라는 한계를 API·DQ-012·발표자료 11장에 명시
- pytest 156, Playwright other-cases 4, build 통과. 발표자료 v3는 서울·포항 캡처와 10·11·17장 문구를 갱신해 다시 빌드
</commit_message>
<xml_diff>
--- a/docs/presentations/FloodOps-2026-v3/FloodOps_최종발표_v3.pptx
+++ b/docs/presentations/FloodOps-2026-v3/FloodOps_최종발표_v3.pptx
@@ -695,7 +695,7 @@
           </a:p>
           <a:p>
             <a:r>
-              <a:t>공식 침수범위가 없어서 침수 건물 수 같은 노출 지표를 내지 않습니다. 사망자나 피해액을 묻는 질문은 Agent가 모델을 부르기 전에 거절합니다. 서울도 지형으로 범위를 만들어 봤지만 공식 침수흔적과 대조하니 아무 정보가 없어서 싣지 않았습니다.</a:t>
+              <a:t>공식 침수범위가 없어서 침수 건물 수 같은 노출 지표를 내지 않습니다. 사망자나 피해액을 묻는 질문은 Agent가 모델을 부르기 전에 거절합니다. 서울의 지형 띠는 공식 침수흔적과 대조하니 회랑 평균과 같아서, 재생용 도식으로만 두고 근거로는 쓰지 않습니다.</a:t>
             </a:r>
           </a:p>
           <a:p>
@@ -1160,7 +1160,7 @@
           </a:p>
           <a:p>
             <a:r>
-              <a:t>다른 사례도 같은 틀입니다. 서울은 공식 침수흔적을 설계강우를 넘은 뒤 깊은 곳부터 드러내고, 포항은 보도된 범람 지점에서 퍼지는 근사 셀, 안동은 하천을 따라 넓어졌다 줄어드는 띠로 보여줍니다. 세 화면 모두 범례에 순서 가정임을 적고, 시나리오 비교 탭은 같은 자리에 있습니다.</a:t>
+              <a:t>다른 사례도 같은 틀입니다. 세 사례 모두 하천을 따라 넓어졌다 줄어드는 붉은 띠로 단계를 보여주고, 서울은 그 위에 공식 침수흔적을 설계강우를 넘은 뒤 깊은 곳부터 드러냅니다. 띠의 근거는 서울은 강우 비율, 포항·안동은 보도 순서이며 범례에 그렇게 적습니다. 시나리오 비교 탭은 같은 자리에 있습니다.</a:t>
             </a:r>
           </a:p>
         </p:txBody>
@@ -7276,14 +7276,14 @@
       </p:sp>
       <p:sp>
         <p:nvSpPr>
-          <p:cNvPr id="25" name="글 흔적을 강우 순서로 표시"/>
+          <p:cNvPr id="25" name="글 흔적 순서 + 강우 비율 띠"/>
           <p:cNvSpPr txBox="1"/>
           <p:nvPr/>
         </p:nvSpPr>
         <p:spPr>
           <a:xfrm>
             <a:off x="9982200" y="3030931"/>
-            <a:ext cx="1505468" cy="217170"/>
+            <a:ext cx="1517485" cy="217170"/>
           </a:xfrm>
           <a:prstGeom prst="rect">
             <a:avLst/>
@@ -7306,7 +7306,7 @@
                 <a:ea typeface="Noto Sans KR"/>
                 <a:cs typeface="Noto Sans KR"/>
               </a:rPr>
-              <a:t>흔적을 강우 순서로 표시</a:t>
+              <a:t>흔적 순서 + 강우 비율 띠</a:t>
             </a:r>
           </a:p>
         </p:txBody>
@@ -7529,14 +7529,14 @@
       </p:sp>
       <p:sp>
         <p:nvSpPr>
-          <p:cNvPr id="32" name="글 보도 순서 HAND 근사"/>
+          <p:cNvPr id="32" name="글 보도 순서 냉천 띠"/>
           <p:cNvSpPr txBox="1"/>
           <p:nvPr/>
         </p:nvSpPr>
         <p:spPr>
           <a:xfrm>
             <a:off x="9982200" y="3594811"/>
-            <a:ext cx="1370388" cy="217170"/>
+            <a:ext cx="1105875" cy="217170"/>
           </a:xfrm>
           <a:prstGeom prst="rect">
             <a:avLst/>
@@ -7559,7 +7559,7 @@
                 <a:ea typeface="Noto Sans KR"/>
                 <a:cs typeface="Noto Sans KR"/>
               </a:rPr>
-              <a:t>보도 순서 HAND 근사</a:t>
+              <a:t>보도 순서 냉천 띠</a:t>
             </a:r>
           </a:p>
         </p:txBody>
@@ -7751,14 +7751,14 @@
       </p:sp>
       <p:sp>
         <p:nvSpPr>
-          <p:cNvPr id="38" name="글 보도 수위 순서 HAND 근사"/>
+          <p:cNvPr id="38" name="글 보도 수위 순서 미천 띠"/>
           <p:cNvSpPr txBox="1"/>
           <p:nvPr/>
         </p:nvSpPr>
         <p:spPr>
           <a:xfrm>
             <a:off x="9982200" y="4158691"/>
-            <a:ext cx="1669214" cy="217170"/>
+            <a:ext cx="1404701" cy="217170"/>
           </a:xfrm>
           <a:prstGeom prst="rect">
             <a:avLst/>
@@ -7781,7 +7781,7 @@
                 <a:ea typeface="Noto Sans KR"/>
                 <a:cs typeface="Noto Sans KR"/>
               </a:rPr>
-              <a:t>보도 수위 순서 HAND 근사</a:t>
+              <a:t>보도 수위 순서 미천 띠</a:t>
             </a:r>
           </a:p>
         </p:txBody>
@@ -8985,14 +8985,14 @@
       </p:sp>
       <p:sp>
         <p:nvSpPr>
-          <p:cNvPr id="23" name="글 서울 DSM 근사는 기각"/>
+          <p:cNvPr id="23" name="글 지형 띠는 근거로 쓰지 않음"/>
           <p:cNvSpPr txBox="1"/>
           <p:nvPr/>
         </p:nvSpPr>
         <p:spPr>
           <a:xfrm>
             <a:off x="8336280" y="2750515"/>
-            <a:ext cx="1779179" cy="274320"/>
+            <a:ext cx="2093001" cy="274320"/>
           </a:xfrm>
           <a:prstGeom prst="rect">
             <a:avLst/>
@@ -9015,7 +9015,7 @@
                 <a:ea typeface="Noto Sans KR"/>
                 <a:cs typeface="Noto Sans KR"/>
               </a:rPr>
-              <a:t>서울 DSM 근사는 기각</a:t>
+              <a:t>지형 띠는 근거로 쓰지 않음</a:t>
             </a:r>
           </a:p>
         </p:txBody>
@@ -9090,7 +9090,7 @@
       </p:sp>
       <p:sp>
         <p:nvSpPr>
-          <p:cNvPr id="26" name="글 서울도 DEM으로 HAND 범위를 만들어 공"/>
+          <p:cNvPr id="26" name="글 서울의 지형 띠를 공식 침수흔적과 대조하니 "/>
           <p:cNvSpPr txBox="1"/>
           <p:nvPr/>
         </p:nvSpPr>
@@ -9124,7 +9124,7 @@
                 <a:ea typeface="Noto Sans KR"/>
                 <a:cs typeface="Noto Sans KR"/>
               </a:rPr>
-              <a:t>서울도 DEM으로 HAND 범위를 만들어 공식</a:t>
+              <a:t>서울의 지형 띠를 공식 침수흔적과 대조하니 임계와</a:t>
             </a:r>
             <a:br/>
             <a:r>
@@ -9136,7 +9136,7 @@
                 <a:ea typeface="Noto Sans KR"/>
                 <a:cs typeface="Noto Sans KR"/>
               </a:rPr>
-              <a:t>침수흔적과 대조했더니 임계와 거리를 어떻게 바꿔도</a:t>
+              <a:t>거리를 어떻게 바꿔도 14~16%만 흔적 위에 있어 회랑</a:t>
             </a:r>
             <a:br/>
             <a:r>
@@ -9148,7 +9148,7 @@
                 <a:ea typeface="Noto Sans KR"/>
                 <a:cs typeface="Noto Sans KR"/>
               </a:rPr>
-              <a:t>14~16%만 흔적 위에 있어 회랑 평균과 같았습니다.</a:t>
+              <a:t>평균과 같았습니다. 그래서 띠는 재생용 도식으로만</a:t>
             </a:r>
             <a:br/>
             <a:r>
@@ -9160,7 +9160,7 @@
                 <a:ea typeface="Noto Sans KR"/>
                 <a:cs typeface="Noto Sans KR"/>
               </a:rPr>
-              <a:t>싣지 않고 흔적도를 강우 순서로 드러냅니다.</a:t>
+              <a:t>두고, 침수 근거는 공식 흔적도만 씁니다.</a:t>
             </a:r>
           </a:p>
         </p:txBody>
@@ -16031,7 +16031,7 @@
       </p:sp>
       <p:sp>
         <p:nvSpPr>
-          <p:cNvPr id="9" name="글 공식 침수흔적 10,468건을 설계강우 초과"/>
+          <p:cNvPr id="9" name="글 도림천 양안 띠가 강우 비율로 넓어지고, 공"/>
           <p:cNvSpPr txBox="1"/>
           <p:nvPr/>
         </p:nvSpPr>
@@ -16065,7 +16065,7 @@
                 <a:ea typeface="Noto Sans KR"/>
                 <a:cs typeface="Noto Sans KR"/>
               </a:rPr>
-              <a:t>공식 침수흔적 10,468건을 설계강우 초과 뒤 깊은 곳부터 드러냄 ·</a:t>
+              <a:t>도림천 양안 띠가 강우 비율로 넓어지고, 공식 침수흔적은 설계강우</a:t>
             </a:r>
             <a:br/>
             <a:r>
@@ -16077,7 +16077,7 @@
                 <a:ea typeface="Noto Sans KR"/>
                 <a:cs typeface="Noto Sans KR"/>
               </a:rPr>
-              <a:t>경보 시각·빗물터널 비교</a:t>
+              <a:t>초과 뒤 깊은 곳부터 드러남 · 경보·빗물터널 비교</a:t>
             </a:r>
           </a:p>
         </p:txBody>
@@ -16183,7 +16183,7 @@
       </p:sp>
       <p:sp>
         <p:nvSpPr>
-          <p:cNvPr id="13" name="글 냉천교에서 퍼지는 HAND 근사 셀(보도 순"/>
+          <p:cNvPr id="13" name="글 냉천 양안 띠가 보도된 사건 순서로 넓어짐("/>
           <p:cNvSpPr txBox="1"/>
           <p:nvPr/>
         </p:nvSpPr>
@@ -16217,7 +16217,7 @@
                 <a:ea typeface="Noto Sans KR"/>
                 <a:cs typeface="Noto Sans KR"/>
               </a:rPr>
-              <a:t>냉천교에서 퍼지는 HAND 근사 셀(보도 순서) · 진입 금지 안내 시각</a:t>
+              <a:t>냉천 양안 띠가 보도된 사건 순서로 넓어짐(HAND 근사) · 진입 금지</a:t>
             </a:r>
             <a:br/>
             <a:r>
@@ -16229,7 +16229,7 @@
                 <a:ea typeface="Noto Sans KR"/>
                 <a:cs typeface="Noto Sans KR"/>
               </a:rPr>
-              <a:t>비교</a:t>
+              <a:t>안내 시각 비교</a:t>
             </a:r>
           </a:p>
         </p:txBody>
@@ -16419,14 +16419,14 @@
       </p:sp>
       <p:sp>
         <p:nvSpPr>
-          <p:cNvPr id="19" name="글 세 화면 모두 범례에 «HAND 근사, 보도"/>
+          <p:cNvPr id="19" name="글 세 화면 모두 하천을 따라 넓어졌다 줄어드는"/>
           <p:cNvSpPr txBox="1"/>
           <p:nvPr/>
         </p:nvSpPr>
         <p:spPr>
           <a:xfrm>
             <a:off x="822960" y="5740298"/>
-            <a:ext cx="6528481" cy="452628"/>
+            <a:ext cx="7491893" cy="452628"/>
           </a:xfrm>
           <a:prstGeom prst="rect">
             <a:avLst/>
@@ -16453,7 +16453,7 @@
                 <a:ea typeface="Noto Sans KR"/>
                 <a:cs typeface="Noto Sans KR"/>
               </a:rPr>
-              <a:t>세 화면 모두 범례에 «HAND 근사, 보도 순서» 또는 «순서 가정»과 현재 건수·셀 수를 적습니다.</a:t>
+              <a:t>세 화면 모두 하천을 따라 넓어졌다 줄어드는 같은 규칙의 붉은 띠이며, 범례에 «HAND 근사»와 현재 셀 수를 적습니다.</a:t>
             </a:r>
           </a:p>
           <a:p>
@@ -16471,7 +16471,7 @@
                 <a:ea typeface="Noto Sans KR"/>
                 <a:cs typeface="Noto Sans KR"/>
               </a:rPr>
-              <a:t>재생 단계를 넘기면 서울 0 → 1,557 → 10,468건, 포항 0 → 78 → 175셀, 안동 605 → 1,073 → 265셀로 바뀝니다.</a:t>
+              <a:t>재생 단계를 넘기면 서울 띠 405 → 1,218셀(흔적 0 → 10,468건), 포항 0 → 236 → 415셀, 안동 605 → 1,073 → 265셀로 바뀝니다.</a:t>
             </a:r>
           </a:p>
         </p:txBody>

</xml_diff>